<commit_message>
IPC: material sin nombres propios inventados (genéricos ZH) + sw v76
Co-Authored-By: Claude Opus 4.8 <noreply@anthropic.com>
</commit_message>
<xml_diff>
--- a/curso/pptx/S01.pptx
+++ b/curso/pptx/S01.pptx
@@ -4303,7 +4303,7 @@
                 </a:solidFill>
                 <a:latin typeface="Nunito Sans"/>
               </a:rPr>
-              <a:t>艾托尔（Aitor）吹牛说：“我是批判性地思考的：我对老师们总是唱反调。”</a:t>
+              <a:t>一个男孩吹牛说：“我是批判性地思考的：我对老师们总是唱反调。”</a:t>
             </a:r>
           </a:p>
         </p:txBody>
@@ -7380,7 +7380,7 @@
                 </a:solidFill>
                 <a:latin typeface="Nunito Sans"/>
               </a:rPr>
-              <a:t>莱雷（Leire）说数学考试在星期四：老师说的时候，她记在了记事本上。</a:t>
+              <a:t>一个女孩说数学考试在星期四：老师说的时候，她记在了记事本上。</a:t>
             </a:r>
           </a:p>
         </p:txBody>

</xml_diff>